<commit_message>
updated metamodel, schema and shapes.
</commit_message>
<xml_diff>
--- a/resources/base logo.pptx
+++ b/resources/base logo.pptx
@@ -5,20 +5,21 @@
     <p:sldMasterId id="2147483648" r:id="rId1"/>
   </p:sldMasterIdLst>
   <p:notesMasterIdLst>
-    <p:notesMasterId r:id="rId13"/>
+    <p:notesMasterId r:id="rId14"/>
   </p:notesMasterIdLst>
   <p:sldIdLst>
     <p:sldId id="291" r:id="rId2"/>
-    <p:sldId id="286" r:id="rId3"/>
-    <p:sldId id="288" r:id="rId4"/>
-    <p:sldId id="289" r:id="rId5"/>
-    <p:sldId id="287" r:id="rId6"/>
-    <p:sldId id="278" r:id="rId7"/>
-    <p:sldId id="285" r:id="rId8"/>
-    <p:sldId id="281" r:id="rId9"/>
-    <p:sldId id="283" r:id="rId10"/>
-    <p:sldId id="284" r:id="rId11"/>
-    <p:sldId id="280" r:id="rId12"/>
+    <p:sldId id="292" r:id="rId3"/>
+    <p:sldId id="286" r:id="rId4"/>
+    <p:sldId id="288" r:id="rId5"/>
+    <p:sldId id="289" r:id="rId6"/>
+    <p:sldId id="287" r:id="rId7"/>
+    <p:sldId id="278" r:id="rId8"/>
+    <p:sldId id="285" r:id="rId9"/>
+    <p:sldId id="281" r:id="rId10"/>
+    <p:sldId id="283" r:id="rId11"/>
+    <p:sldId id="284" r:id="rId12"/>
+    <p:sldId id="280" r:id="rId13"/>
   </p:sldIdLst>
   <p:sldSz cx="12192000" cy="6858000"/>
   <p:notesSz cx="6858000" cy="9144000"/>
@@ -120,22 +121,27 @@
   <p:extLst>
     <p:ext uri="{EFAFB233-063F-42B5-8137-9DF3F51BA10A}">
       <p15:sldGuideLst xmlns:p15="http://schemas.microsoft.com/office/powerpoint/2012/main">
-        <p15:guide id="1" orient="horz" pos="2908" userDrawn="1">
+        <p15:guide id="1" orient="horz" pos="2364" userDrawn="1">
           <p15:clr>
             <a:srgbClr val="A4A3A4"/>
           </p15:clr>
         </p15:guide>
-        <p15:guide id="2" pos="2819" userDrawn="1">
+        <p15:guide id="3" pos="6743" userDrawn="1">
           <p15:clr>
             <a:srgbClr val="A4A3A4"/>
           </p15:clr>
         </p15:guide>
-        <p15:guide id="3" pos="5314" userDrawn="1">
+        <p15:guide id="4" pos="4248" userDrawn="1">
           <p15:clr>
             <a:srgbClr val="A4A3A4"/>
           </p15:clr>
         </p15:guide>
-        <p15:guide id="4" pos="4452" userDrawn="1">
+        <p15:guide id="5" pos="2910" userDrawn="1">
+          <p15:clr>
+            <a:srgbClr val="A4A3A4"/>
+          </p15:clr>
+        </p15:guide>
+        <p15:guide id="6" pos="6879" userDrawn="1">
           <p15:clr>
             <a:srgbClr val="A4A3A4"/>
           </p15:clr>
@@ -228,7 +234,7 @@
           <a:p>
             <a:fld id="{DC0890D7-75A3-4AFD-AFCE-7BC66DB681C5}" type="datetimeFigureOut">
               <a:rPr lang="en-150" smtClean="0"/>
-              <a:t>30/08/2024</a:t>
+              <a:t>28/01/2025</a:t>
             </a:fld>
             <a:endParaRPr lang="en-150"/>
           </a:p>
@@ -645,7 +651,7 @@
           <a:p>
             <a:fld id="{97A7BB66-1ADB-47C6-8EE2-F72BFA79F05A}" type="datetimeFigureOut">
               <a:rPr lang="en-150" smtClean="0"/>
-              <a:t>30/08/2024</a:t>
+              <a:t>28/01/2025</a:t>
             </a:fld>
             <a:endParaRPr lang="en-150"/>
           </a:p>
@@ -861,7 +867,7 @@
           <a:p>
             <a:fld id="{97A7BB66-1ADB-47C6-8EE2-F72BFA79F05A}" type="datetimeFigureOut">
               <a:rPr lang="en-150" smtClean="0"/>
-              <a:t>30/08/2024</a:t>
+              <a:t>28/01/2025</a:t>
             </a:fld>
             <a:endParaRPr lang="en-150"/>
           </a:p>
@@ -1071,7 +1077,7 @@
           <a:p>
             <a:fld id="{97A7BB66-1ADB-47C6-8EE2-F72BFA79F05A}" type="datetimeFigureOut">
               <a:rPr lang="en-150" smtClean="0"/>
-              <a:t>30/08/2024</a:t>
+              <a:t>28/01/2025</a:t>
             </a:fld>
             <a:endParaRPr lang="en-150"/>
           </a:p>
@@ -1271,7 +1277,7 @@
           <a:p>
             <a:fld id="{97A7BB66-1ADB-47C6-8EE2-F72BFA79F05A}" type="datetimeFigureOut">
               <a:rPr lang="en-150" smtClean="0"/>
-              <a:t>30/08/2024</a:t>
+              <a:t>28/01/2025</a:t>
             </a:fld>
             <a:endParaRPr lang="en-150"/>
           </a:p>
@@ -1563,7 +1569,7 @@
           <a:p>
             <a:fld id="{97A7BB66-1ADB-47C6-8EE2-F72BFA79F05A}" type="datetimeFigureOut">
               <a:rPr lang="en-150" smtClean="0"/>
-              <a:t>30/08/2024</a:t>
+              <a:t>28/01/2025</a:t>
             </a:fld>
             <a:endParaRPr lang="en-150"/>
           </a:p>
@@ -1831,7 +1837,7 @@
           <a:p>
             <a:fld id="{97A7BB66-1ADB-47C6-8EE2-F72BFA79F05A}" type="datetimeFigureOut">
               <a:rPr lang="en-150" smtClean="0"/>
-              <a:t>30/08/2024</a:t>
+              <a:t>28/01/2025</a:t>
             </a:fld>
             <a:endParaRPr lang="en-150"/>
           </a:p>
@@ -2246,7 +2252,7 @@
           <a:p>
             <a:fld id="{97A7BB66-1ADB-47C6-8EE2-F72BFA79F05A}" type="datetimeFigureOut">
               <a:rPr lang="en-150" smtClean="0"/>
-              <a:t>30/08/2024</a:t>
+              <a:t>28/01/2025</a:t>
             </a:fld>
             <a:endParaRPr lang="en-150"/>
           </a:p>
@@ -2388,7 +2394,7 @@
           <a:p>
             <a:fld id="{97A7BB66-1ADB-47C6-8EE2-F72BFA79F05A}" type="datetimeFigureOut">
               <a:rPr lang="en-150" smtClean="0"/>
-              <a:t>30/08/2024</a:t>
+              <a:t>28/01/2025</a:t>
             </a:fld>
             <a:endParaRPr lang="en-150"/>
           </a:p>
@@ -2501,7 +2507,7 @@
           <a:p>
             <a:fld id="{97A7BB66-1ADB-47C6-8EE2-F72BFA79F05A}" type="datetimeFigureOut">
               <a:rPr lang="en-150" smtClean="0"/>
-              <a:t>30/08/2024</a:t>
+              <a:t>28/01/2025</a:t>
             </a:fld>
             <a:endParaRPr lang="en-150"/>
           </a:p>
@@ -2814,7 +2820,7 @@
           <a:p>
             <a:fld id="{97A7BB66-1ADB-47C6-8EE2-F72BFA79F05A}" type="datetimeFigureOut">
               <a:rPr lang="en-150" smtClean="0"/>
-              <a:t>30/08/2024</a:t>
+              <a:t>28/01/2025</a:t>
             </a:fld>
             <a:endParaRPr lang="en-150"/>
           </a:p>
@@ -3103,7 +3109,7 @@
           <a:p>
             <a:fld id="{97A7BB66-1ADB-47C6-8EE2-F72BFA79F05A}" type="datetimeFigureOut">
               <a:rPr lang="en-150" smtClean="0"/>
-              <a:t>30/08/2024</a:t>
+              <a:t>28/01/2025</a:t>
             </a:fld>
             <a:endParaRPr lang="en-150"/>
           </a:p>
@@ -3345,7 +3351,7 @@
           <a:p>
             <a:fld id="{97A7BB66-1ADB-47C6-8EE2-F72BFA79F05A}" type="datetimeFigureOut">
               <a:rPr lang="en-150" smtClean="0"/>
-              <a:t>30/08/2024</a:t>
+              <a:t>28/01/2025</a:t>
             </a:fld>
             <a:endParaRPr lang="en-150"/>
           </a:p>
@@ -4596,6 +4602,262 @@
               <a:avLst/>
             </a:prstGeom>
             <a:solidFill>
+              <a:srgbClr val="FF6F61"/>
+            </a:solidFill>
+            <a:ln>
+              <a:noFill/>
+            </a:ln>
+          </p:spPr>
+          <p:style>
+            <a:lnRef idx="2">
+              <a:schemeClr val="accent1">
+                <a:shade val="15000"/>
+              </a:schemeClr>
+            </a:lnRef>
+            <a:fillRef idx="1">
+              <a:schemeClr val="accent1"/>
+            </a:fillRef>
+            <a:effectRef idx="0">
+              <a:schemeClr val="accent1"/>
+            </a:effectRef>
+            <a:fontRef idx="minor">
+              <a:schemeClr val="lt1"/>
+            </a:fontRef>
+          </p:style>
+          <p:txBody>
+            <a:bodyPr rtlCol="0" anchor="ctr"/>
+            <a:lstStyle/>
+            <a:p>
+              <a:pPr algn="ctr"/>
+              <a:endParaRPr lang="en-150"/>
+            </a:p>
+          </p:txBody>
+        </p:sp>
+      </p:grpSp>
+      <p:sp>
+        <p:nvSpPr>
+          <p:cNvPr id="2" name="TextBox 1">
+            <a:extLst>
+              <a:ext uri="{FF2B5EF4-FFF2-40B4-BE49-F238E27FC236}">
+                <a16:creationId xmlns:a16="http://schemas.microsoft.com/office/drawing/2014/main" id="{5DF106CF-89D1-049C-3FD4-88578CB84BF1}"/>
+              </a:ext>
+            </a:extLst>
+          </p:cNvPr>
+          <p:cNvSpPr txBox="1"/>
+          <p:nvPr/>
+        </p:nvSpPr>
+        <p:spPr>
+          <a:xfrm>
+            <a:off x="4344360" y="3218689"/>
+            <a:ext cx="4253087" cy="1200329"/>
+          </a:xfrm>
+          <a:prstGeom prst="rect">
+            <a:avLst/>
+          </a:prstGeom>
+          <a:noFill/>
+        </p:spPr>
+        <p:txBody>
+          <a:bodyPr wrap="none" rtlCol="0">
+            <a:spAutoFit/>
+          </a:bodyPr>
+          <a:lstStyle/>
+          <a:p>
+            <a:r>
+              <a:rPr lang="en-US" sz="7200" dirty="0">
+                <a:solidFill>
+                  <a:srgbClr val="1A1F71"/>
+                </a:solidFill>
+                <a:latin typeface="Aafia" pitchFamily="50" charset="0"/>
+              </a:rPr>
+              <a:t>LaDe</a:t>
+            </a:r>
+            <a:r>
+              <a:rPr lang="en-US" sz="7200" dirty="0">
+                <a:solidFill>
+                  <a:srgbClr val="FF6F61"/>
+                </a:solidFill>
+                <a:latin typeface="Aafia" pitchFamily="50" charset="0"/>
+              </a:rPr>
+              <a:t>RR</a:t>
+            </a:r>
+          </a:p>
+        </p:txBody>
+      </p:sp>
+    </p:spTree>
+    <p:extLst>
+      <p:ext uri="{BB962C8B-B14F-4D97-AF65-F5344CB8AC3E}">
+        <p14:creationId xmlns:p14="http://schemas.microsoft.com/office/powerpoint/2010/main" val="2663385008"/>
+      </p:ext>
+    </p:extLst>
+  </p:cSld>
+  <p:clrMapOvr>
+    <a:masterClrMapping/>
+  </p:clrMapOvr>
+</p:sld>
+</file>
+
+<file path=ppt/slides/slide11.xml><?xml version="1.0" encoding="utf-8"?>
+<p:sld xmlns:a="http://schemas.openxmlformats.org/drawingml/2006/main" xmlns:r="http://schemas.openxmlformats.org/officeDocument/2006/relationships" xmlns:p="http://schemas.openxmlformats.org/presentationml/2006/main">
+  <p:cSld>
+    <p:spTree>
+      <p:nvGrpSpPr>
+        <p:cNvPr id="1" name=""/>
+        <p:cNvGrpSpPr/>
+        <p:nvPr/>
+      </p:nvGrpSpPr>
+      <p:grpSpPr>
+        <a:xfrm>
+          <a:off x="0" y="0"/>
+          <a:ext cx="0" cy="0"/>
+          <a:chOff x="0" y="0"/>
+          <a:chExt cx="0" cy="0"/>
+        </a:xfrm>
+      </p:grpSpPr>
+      <p:grpSp>
+        <p:nvGrpSpPr>
+          <p:cNvPr id="9" name="Group 8">
+            <a:extLst>
+              <a:ext uri="{FF2B5EF4-FFF2-40B4-BE49-F238E27FC236}">
+                <a16:creationId xmlns:a16="http://schemas.microsoft.com/office/drawing/2014/main" id="{2590A2DE-16F5-44B0-79F7-D9518568AB64}"/>
+              </a:ext>
+            </a:extLst>
+          </p:cNvPr>
+          <p:cNvGrpSpPr/>
+          <p:nvPr/>
+        </p:nvGrpSpPr>
+        <p:grpSpPr>
+          <a:xfrm>
+            <a:off x="4468368" y="1625169"/>
+            <a:ext cx="3959748" cy="1566088"/>
+            <a:chOff x="4468368" y="1563624"/>
+            <a:chExt cx="4531517" cy="1792224"/>
+          </a:xfrm>
+        </p:grpSpPr>
+        <p:sp>
+          <p:nvSpPr>
+            <p:cNvPr id="6" name="Rectangle 5">
+              <a:extLst>
+                <a:ext uri="{FF2B5EF4-FFF2-40B4-BE49-F238E27FC236}">
+                  <a16:creationId xmlns:a16="http://schemas.microsoft.com/office/drawing/2014/main" id="{011E5DD6-E9CE-0E04-DAAC-92581C64AEF3}"/>
+                </a:ext>
+              </a:extLst>
+            </p:cNvPr>
+            <p:cNvSpPr/>
+            <p:nvPr/>
+          </p:nvSpPr>
+          <p:spPr>
+            <a:xfrm>
+              <a:off x="4468368" y="2990088"/>
+              <a:ext cx="1627632" cy="365760"/>
+            </a:xfrm>
+            <a:prstGeom prst="rect">
+              <a:avLst/>
+            </a:prstGeom>
+            <a:solidFill>
+              <a:srgbClr val="1A1F71"/>
+            </a:solidFill>
+            <a:ln>
+              <a:noFill/>
+            </a:ln>
+          </p:spPr>
+          <p:style>
+            <a:lnRef idx="2">
+              <a:schemeClr val="accent1">
+                <a:shade val="15000"/>
+              </a:schemeClr>
+            </a:lnRef>
+            <a:fillRef idx="1">
+              <a:schemeClr val="accent1"/>
+            </a:fillRef>
+            <a:effectRef idx="0">
+              <a:schemeClr val="accent1"/>
+            </a:effectRef>
+            <a:fontRef idx="minor">
+              <a:schemeClr val="lt1"/>
+            </a:fontRef>
+          </p:style>
+          <p:txBody>
+            <a:bodyPr rtlCol="0" anchor="ctr"/>
+            <a:lstStyle/>
+            <a:p>
+              <a:pPr algn="ctr"/>
+              <a:endParaRPr lang="en-150"/>
+            </a:p>
+          </p:txBody>
+        </p:sp>
+        <p:sp>
+          <p:nvSpPr>
+            <p:cNvPr id="7" name="Rectangle 6">
+              <a:extLst>
+                <a:ext uri="{FF2B5EF4-FFF2-40B4-BE49-F238E27FC236}">
+                  <a16:creationId xmlns:a16="http://schemas.microsoft.com/office/drawing/2014/main" id="{4E011A50-3FA0-A8E8-8DF5-1CBB2DF4C4FE}"/>
+                </a:ext>
+              </a:extLst>
+            </p:cNvPr>
+            <p:cNvSpPr/>
+            <p:nvPr/>
+          </p:nvSpPr>
+          <p:spPr>
+            <a:xfrm>
+              <a:off x="5920312" y="2276856"/>
+              <a:ext cx="1627632" cy="365760"/>
+            </a:xfrm>
+            <a:prstGeom prst="rect">
+              <a:avLst/>
+            </a:prstGeom>
+            <a:solidFill>
+              <a:srgbClr val="1A1F71"/>
+            </a:solidFill>
+            <a:ln>
+              <a:noFill/>
+            </a:ln>
+          </p:spPr>
+          <p:style>
+            <a:lnRef idx="2">
+              <a:schemeClr val="accent1">
+                <a:shade val="15000"/>
+              </a:schemeClr>
+            </a:lnRef>
+            <a:fillRef idx="1">
+              <a:schemeClr val="accent1"/>
+            </a:fillRef>
+            <a:effectRef idx="0">
+              <a:schemeClr val="accent1"/>
+            </a:effectRef>
+            <a:fontRef idx="minor">
+              <a:schemeClr val="lt1"/>
+            </a:fontRef>
+          </p:style>
+          <p:txBody>
+            <a:bodyPr rtlCol="0" anchor="ctr"/>
+            <a:lstStyle/>
+            <a:p>
+              <a:pPr algn="ctr"/>
+              <a:endParaRPr lang="en-150"/>
+            </a:p>
+          </p:txBody>
+        </p:sp>
+        <p:sp>
+          <p:nvSpPr>
+            <p:cNvPr id="8" name="Rectangle 7">
+              <a:extLst>
+                <a:ext uri="{FF2B5EF4-FFF2-40B4-BE49-F238E27FC236}">
+                  <a16:creationId xmlns:a16="http://schemas.microsoft.com/office/drawing/2014/main" id="{78B4BDD1-236D-438B-09EB-97CA895C3300}"/>
+                </a:ext>
+              </a:extLst>
+            </p:cNvPr>
+            <p:cNvSpPr/>
+            <p:nvPr/>
+          </p:nvSpPr>
+          <p:spPr>
+            <a:xfrm>
+              <a:off x="7372256" y="1563624"/>
+              <a:ext cx="1627629" cy="365760"/>
+            </a:xfrm>
+            <a:prstGeom prst="rect">
+              <a:avLst/>
+            </a:prstGeom>
+            <a:solidFill>
               <a:srgbClr val="FFD700"/>
             </a:solidFill>
             <a:ln>
@@ -4690,7 +4952,7 @@
 </p:sld>
 </file>
 
-<file path=ppt/slides/slide11.xml><?xml version="1.0" encoding="utf-8"?>
+<file path=ppt/slides/slide12.xml><?xml version="1.0" encoding="utf-8"?>
 <p:sld xmlns:a="http://schemas.openxmlformats.org/drawingml/2006/main" xmlns:r="http://schemas.openxmlformats.org/officeDocument/2006/relationships" xmlns:p="http://schemas.openxmlformats.org/presentationml/2006/main">
   <p:cSld>
     <p:spTree>
@@ -4952,6 +5214,382 @@
   <p:cSld>
     <p:spTree>
       <p:nvGrpSpPr>
+        <p:cNvPr id="1" name="">
+          <a:extLst>
+            <a:ext uri="{FF2B5EF4-FFF2-40B4-BE49-F238E27FC236}">
+              <a16:creationId xmlns:a16="http://schemas.microsoft.com/office/drawing/2014/main" id="{17A2AECE-803C-C14D-92EA-045167590D42}"/>
+            </a:ext>
+          </a:extLst>
+        </p:cNvPr>
+        <p:cNvGrpSpPr/>
+        <p:nvPr/>
+      </p:nvGrpSpPr>
+      <p:grpSpPr>
+        <a:xfrm>
+          <a:off x="0" y="0"/>
+          <a:ext cx="0" cy="0"/>
+          <a:chOff x="0" y="0"/>
+          <a:chExt cx="0" cy="0"/>
+        </a:xfrm>
+      </p:grpSpPr>
+      <p:sp>
+        <p:nvSpPr>
+          <p:cNvPr id="12" name="Rectangle 11">
+            <a:extLst>
+              <a:ext uri="{FF2B5EF4-FFF2-40B4-BE49-F238E27FC236}">
+                <a16:creationId xmlns:a16="http://schemas.microsoft.com/office/drawing/2014/main" id="{CC1452E2-4D60-D378-BB0A-32DCEAC90159}"/>
+              </a:ext>
+            </a:extLst>
+          </p:cNvPr>
+          <p:cNvSpPr/>
+          <p:nvPr/>
+        </p:nvSpPr>
+        <p:spPr>
+          <a:xfrm>
+            <a:off x="6734175" y="2759041"/>
+            <a:ext cx="1223963" cy="149432"/>
+          </a:xfrm>
+          <a:prstGeom prst="rect">
+            <a:avLst/>
+          </a:prstGeom>
+          <a:solidFill>
+            <a:srgbClr val="1A1F71"/>
+          </a:solidFill>
+          <a:ln w="3175">
+            <a:noFill/>
+          </a:ln>
+          <a:effectLst/>
+          <a:scene3d>
+            <a:camera prst="orthographicFront"/>
+            <a:lightRig rig="threePt" dir="t"/>
+          </a:scene3d>
+          <a:sp3d>
+            <a:bevelT w="38100" h="38100"/>
+          </a:sp3d>
+        </p:spPr>
+        <p:style>
+          <a:lnRef idx="2">
+            <a:schemeClr val="accent1">
+              <a:shade val="15000"/>
+            </a:schemeClr>
+          </a:lnRef>
+          <a:fillRef idx="1">
+            <a:schemeClr val="accent1"/>
+          </a:fillRef>
+          <a:effectRef idx="0">
+            <a:schemeClr val="accent1"/>
+          </a:effectRef>
+          <a:fontRef idx="minor">
+            <a:schemeClr val="lt1"/>
+          </a:fontRef>
+        </p:style>
+        <p:txBody>
+          <a:bodyPr rtlCol="0" anchor="ctr"/>
+          <a:lstStyle/>
+          <a:p>
+            <a:pPr algn="ctr"/>
+            <a:endParaRPr lang="en-150">
+              <a:solidFill>
+                <a:srgbClr val="1A1F71"/>
+              </a:solidFill>
+            </a:endParaRPr>
+          </a:p>
+        </p:txBody>
+      </p:sp>
+      <p:sp>
+        <p:nvSpPr>
+          <p:cNvPr id="13" name="Rectangle 12">
+            <a:extLst>
+              <a:ext uri="{FF2B5EF4-FFF2-40B4-BE49-F238E27FC236}">
+                <a16:creationId xmlns:a16="http://schemas.microsoft.com/office/drawing/2014/main" id="{51D456FA-1BB7-2DC0-1C94-925D5EB7A450}"/>
+              </a:ext>
+            </a:extLst>
+          </p:cNvPr>
+          <p:cNvSpPr/>
+          <p:nvPr/>
+        </p:nvSpPr>
+        <p:spPr>
+          <a:xfrm>
+            <a:off x="7958138" y="2601989"/>
+            <a:ext cx="1368425" cy="149432"/>
+          </a:xfrm>
+          <a:prstGeom prst="rect">
+            <a:avLst/>
+          </a:prstGeom>
+          <a:solidFill>
+            <a:srgbClr val="1A1F71"/>
+          </a:solidFill>
+          <a:ln w="3175">
+            <a:noFill/>
+          </a:ln>
+          <a:effectLst/>
+          <a:scene3d>
+            <a:camera prst="orthographicFront"/>
+            <a:lightRig rig="threePt" dir="t"/>
+          </a:scene3d>
+          <a:sp3d>
+            <a:bevelT w="38100" h="38100"/>
+          </a:sp3d>
+        </p:spPr>
+        <p:style>
+          <a:lnRef idx="2">
+            <a:schemeClr val="accent1">
+              <a:shade val="15000"/>
+            </a:schemeClr>
+          </a:lnRef>
+          <a:fillRef idx="1">
+            <a:schemeClr val="accent1"/>
+          </a:fillRef>
+          <a:effectRef idx="0">
+            <a:schemeClr val="accent1"/>
+          </a:effectRef>
+          <a:fontRef idx="minor">
+            <a:schemeClr val="lt1"/>
+          </a:fontRef>
+        </p:style>
+        <p:txBody>
+          <a:bodyPr rtlCol="0" anchor="ctr"/>
+          <a:lstStyle/>
+          <a:p>
+            <a:pPr algn="ctr"/>
+            <a:endParaRPr lang="en-150">
+              <a:solidFill>
+                <a:srgbClr val="1A1F71"/>
+              </a:solidFill>
+            </a:endParaRPr>
+          </a:p>
+        </p:txBody>
+      </p:sp>
+      <p:sp>
+        <p:nvSpPr>
+          <p:cNvPr id="14" name="Rectangle 13">
+            <a:extLst>
+              <a:ext uri="{FF2B5EF4-FFF2-40B4-BE49-F238E27FC236}">
+                <a16:creationId xmlns:a16="http://schemas.microsoft.com/office/drawing/2014/main" id="{D3BE7271-8349-F22F-6698-DE676C5590AF}"/>
+              </a:ext>
+            </a:extLst>
+          </p:cNvPr>
+          <p:cNvSpPr/>
+          <p:nvPr/>
+        </p:nvSpPr>
+        <p:spPr>
+          <a:xfrm>
+            <a:off x="9326564" y="2444937"/>
+            <a:ext cx="1377950" cy="149432"/>
+          </a:xfrm>
+          <a:prstGeom prst="rect">
+            <a:avLst/>
+          </a:prstGeom>
+          <a:gradFill flip="none" rotWithShape="1">
+            <a:gsLst>
+              <a:gs pos="0">
+                <a:srgbClr val="FFD700"/>
+              </a:gs>
+              <a:gs pos="78000">
+                <a:srgbClr val="FFD700"/>
+              </a:gs>
+              <a:gs pos="100000">
+                <a:schemeClr val="bg1"/>
+              </a:gs>
+            </a:gsLst>
+            <a:lin ang="18900000" scaled="1"/>
+            <a:tileRect/>
+          </a:gradFill>
+          <a:ln w="3175">
+            <a:noFill/>
+          </a:ln>
+          <a:effectLst/>
+          <a:scene3d>
+            <a:camera prst="orthographicFront"/>
+            <a:lightRig rig="threePt" dir="t"/>
+          </a:scene3d>
+          <a:sp3d>
+            <a:bevelT w="38100" h="38100"/>
+          </a:sp3d>
+        </p:spPr>
+        <p:style>
+          <a:lnRef idx="2">
+            <a:schemeClr val="accent1">
+              <a:shade val="15000"/>
+            </a:schemeClr>
+          </a:lnRef>
+          <a:fillRef idx="1">
+            <a:schemeClr val="accent1"/>
+          </a:fillRef>
+          <a:effectRef idx="0">
+            <a:schemeClr val="accent1"/>
+          </a:effectRef>
+          <a:fontRef idx="minor">
+            <a:schemeClr val="lt1"/>
+          </a:fontRef>
+        </p:style>
+        <p:txBody>
+          <a:bodyPr rtlCol="0" anchor="ctr"/>
+          <a:lstStyle/>
+          <a:p>
+            <a:pPr algn="ctr"/>
+            <a:endParaRPr lang="en-150"/>
+          </a:p>
+        </p:txBody>
+      </p:sp>
+      <p:sp>
+        <p:nvSpPr>
+          <p:cNvPr id="15" name="TextBox 14">
+            <a:extLst>
+              <a:ext uri="{FF2B5EF4-FFF2-40B4-BE49-F238E27FC236}">
+                <a16:creationId xmlns:a16="http://schemas.microsoft.com/office/drawing/2014/main" id="{3505A1EF-63A0-4328-4BA7-163C3DDE54F0}"/>
+              </a:ext>
+            </a:extLst>
+          </p:cNvPr>
+          <p:cNvSpPr txBox="1"/>
+          <p:nvPr/>
+        </p:nvSpPr>
+        <p:spPr>
+          <a:xfrm>
+            <a:off x="6606889" y="2855133"/>
+            <a:ext cx="4253087" cy="1200329"/>
+          </a:xfrm>
+          <a:prstGeom prst="rect">
+            <a:avLst/>
+          </a:prstGeom>
+          <a:noFill/>
+          <a:ln>
+            <a:noFill/>
+          </a:ln>
+          <a:effectLst/>
+        </p:spPr>
+        <p:txBody>
+          <a:bodyPr wrap="none" rtlCol="0">
+            <a:spAutoFit/>
+            <a:scene3d>
+              <a:camera prst="orthographicFront"/>
+              <a:lightRig rig="threePt" dir="t"/>
+            </a:scene3d>
+            <a:sp3d extrusionH="38100">
+              <a:bevelT w="38100" h="38100"/>
+            </a:sp3d>
+          </a:bodyPr>
+          <a:lstStyle/>
+          <a:p>
+            <a:r>
+              <a:rPr lang="en-US" sz="7200" dirty="0">
+                <a:ln w="3175">
+                  <a:noFill/>
+                </a:ln>
+                <a:solidFill>
+                  <a:srgbClr val="1A1F71"/>
+                </a:solidFill>
+                <a:latin typeface="Aafia" pitchFamily="50" charset="0"/>
+              </a:rPr>
+              <a:t>LaDe</a:t>
+            </a:r>
+            <a:r>
+              <a:rPr lang="en-US" sz="7200" dirty="0">
+                <a:ln w="3175">
+                  <a:noFill/>
+                </a:ln>
+                <a:gradFill flip="none" rotWithShape="1">
+                  <a:gsLst>
+                    <a:gs pos="80000">
+                      <a:srgbClr val="FFD700"/>
+                    </a:gs>
+                    <a:gs pos="0">
+                      <a:srgbClr val="FFD700"/>
+                    </a:gs>
+                    <a:gs pos="100000">
+                      <a:schemeClr val="bg1"/>
+                    </a:gs>
+                  </a:gsLst>
+                  <a:lin ang="18900000" scaled="1"/>
+                  <a:tileRect/>
+                </a:gradFill>
+                <a:latin typeface="Aafia" pitchFamily="50" charset="0"/>
+              </a:rPr>
+              <a:t>RR</a:t>
+            </a:r>
+          </a:p>
+        </p:txBody>
+      </p:sp>
+      <p:sp>
+        <p:nvSpPr>
+          <p:cNvPr id="19" name="TextBox 18">
+            <a:extLst>
+              <a:ext uri="{FF2B5EF4-FFF2-40B4-BE49-F238E27FC236}">
+                <a16:creationId xmlns:a16="http://schemas.microsoft.com/office/drawing/2014/main" id="{DC54A8A1-F903-CEBA-6CFE-33F719E328FD}"/>
+              </a:ext>
+            </a:extLst>
+          </p:cNvPr>
+          <p:cNvSpPr txBox="1"/>
+          <p:nvPr/>
+        </p:nvSpPr>
+        <p:spPr>
+          <a:xfrm>
+            <a:off x="6713538" y="3578479"/>
+            <a:ext cx="4411662" cy="830997"/>
+          </a:xfrm>
+          <a:prstGeom prst="rect">
+            <a:avLst/>
+          </a:prstGeom>
+          <a:noFill/>
+          <a:ln>
+            <a:noFill/>
+          </a:ln>
+          <a:effectLst>
+            <a:outerShdw blurRad="44450" dist="27940" dir="5400000" algn="ctr">
+              <a:srgbClr val="000000">
+                <a:alpha val="32000"/>
+              </a:srgbClr>
+            </a:outerShdw>
+          </a:effectLst>
+          <a:scene3d>
+            <a:camera prst="orthographicFront">
+              <a:rot lat="0" lon="0" rev="0"/>
+            </a:camera>
+            <a:lightRig rig="balanced" dir="t">
+              <a:rot lat="0" lon="0" rev="8700000"/>
+            </a:lightRig>
+          </a:scene3d>
+          <a:sp3d>
+            <a:bevelT w="190500" h="38100"/>
+          </a:sp3d>
+        </p:spPr>
+        <p:txBody>
+          <a:bodyPr wrap="square" lIns="0" tIns="0" rIns="0" bIns="0" rtlCol="0">
+            <a:spAutoFit/>
+          </a:bodyPr>
+          <a:lstStyle/>
+          <a:p>
+            <a:pPr algn="just"/>
+            <a:r>
+              <a:rPr lang="en-US" sz="5400" b="1" spc="780" dirty="0">
+                <a:solidFill>
+                  <a:srgbClr val="97258F"/>
+                </a:solidFill>
+                <a:latin typeface="Engravers MT" panose="02090707080505020304" pitchFamily="18" charset="0"/>
+              </a:rPr>
+              <a:t>Engine</a:t>
+            </a:r>
+          </a:p>
+        </p:txBody>
+      </p:sp>
+    </p:spTree>
+    <p:extLst>
+      <p:ext uri="{BB962C8B-B14F-4D97-AF65-F5344CB8AC3E}">
+        <p14:creationId xmlns:p14="http://schemas.microsoft.com/office/powerpoint/2010/main" val="1047741798"/>
+      </p:ext>
+    </p:extLst>
+  </p:cSld>
+  <p:clrMapOvr>
+    <a:masterClrMapping/>
+  </p:clrMapOvr>
+</p:sld>
+</file>
+
+<file path=ppt/slides/slide3.xml><?xml version="1.0" encoding="utf-8"?>
+<p:sld xmlns:a="http://schemas.openxmlformats.org/drawingml/2006/main" xmlns:r="http://schemas.openxmlformats.org/officeDocument/2006/relationships" xmlns:p="http://schemas.openxmlformats.org/presentationml/2006/main">
+  <p:cSld>
+    <p:spTree>
+      <p:nvGrpSpPr>
         <p:cNvPr id="1" name=""/>
         <p:cNvGrpSpPr/>
         <p:nvPr/>
@@ -5283,7 +5921,7 @@
 </p:sld>
 </file>
 
-<file path=ppt/slides/slide3.xml><?xml version="1.0" encoding="utf-8"?>
+<file path=ppt/slides/slide4.xml><?xml version="1.0" encoding="utf-8"?>
 <p:sld xmlns:a="http://schemas.openxmlformats.org/drawingml/2006/main" xmlns:r="http://schemas.openxmlformats.org/officeDocument/2006/relationships" xmlns:p="http://schemas.openxmlformats.org/presentationml/2006/main">
   <p:cSld>
     <p:spTree>
@@ -5621,7 +6259,7 @@
 </p:sld>
 </file>
 
-<file path=ppt/slides/slide4.xml><?xml version="1.0" encoding="utf-8"?>
+<file path=ppt/slides/slide5.xml><?xml version="1.0" encoding="utf-8"?>
 <p:sld xmlns:a="http://schemas.openxmlformats.org/drawingml/2006/main" xmlns:r="http://schemas.openxmlformats.org/officeDocument/2006/relationships" xmlns:p="http://schemas.openxmlformats.org/presentationml/2006/main">
   <p:cSld>
     <p:spTree>
@@ -5901,7 +6539,7 @@
 </p:sld>
 </file>
 
-<file path=ppt/slides/slide5.xml><?xml version="1.0" encoding="utf-8"?>
+<file path=ppt/slides/slide6.xml><?xml version="1.0" encoding="utf-8"?>
 <p:sld xmlns:a="http://schemas.openxmlformats.org/drawingml/2006/main" xmlns:r="http://schemas.openxmlformats.org/officeDocument/2006/relationships" xmlns:p="http://schemas.openxmlformats.org/presentationml/2006/main">
   <p:cSld>
     <p:spTree>
@@ -6173,7 +6811,7 @@
 </p:sld>
 </file>
 
-<file path=ppt/slides/slide6.xml><?xml version="1.0" encoding="utf-8"?>
+<file path=ppt/slides/slide7.xml><?xml version="1.0" encoding="utf-8"?>
 <p:sld xmlns:a="http://schemas.openxmlformats.org/drawingml/2006/main" xmlns:r="http://schemas.openxmlformats.org/officeDocument/2006/relationships" xmlns:p="http://schemas.openxmlformats.org/presentationml/2006/main">
   <p:cSld>
     <p:spTree>
@@ -6423,7 +7061,7 @@
 </p:sld>
 </file>
 
-<file path=ppt/slides/slide7.xml><?xml version="1.0" encoding="utf-8"?>
+<file path=ppt/slides/slide8.xml><?xml version="1.0" encoding="utf-8"?>
 <p:sld xmlns:a="http://schemas.openxmlformats.org/drawingml/2006/main" xmlns:r="http://schemas.openxmlformats.org/officeDocument/2006/relationships" xmlns:p="http://schemas.openxmlformats.org/presentationml/2006/main">
   <p:cSld>
     <p:spTree>
@@ -6857,7 +7495,7 @@
 </p:sld>
 </file>
 
-<file path=ppt/slides/slide8.xml><?xml version="1.0" encoding="utf-8"?>
+<file path=ppt/slides/slide9.xml><?xml version="1.0" encoding="utf-8"?>
 <p:sld xmlns:a="http://schemas.openxmlformats.org/drawingml/2006/main" xmlns:r="http://schemas.openxmlformats.org/officeDocument/2006/relationships" xmlns:p="http://schemas.openxmlformats.org/presentationml/2006/main">
   <p:cSld>
     <p:spTree>
@@ -7104,262 +7742,6 @@
     <p:extLst>
       <p:ext uri="{BB962C8B-B14F-4D97-AF65-F5344CB8AC3E}">
         <p14:creationId xmlns:p14="http://schemas.microsoft.com/office/powerpoint/2010/main" val="3677000309"/>
-      </p:ext>
-    </p:extLst>
-  </p:cSld>
-  <p:clrMapOvr>
-    <a:masterClrMapping/>
-  </p:clrMapOvr>
-</p:sld>
-</file>
-
-<file path=ppt/slides/slide9.xml><?xml version="1.0" encoding="utf-8"?>
-<p:sld xmlns:a="http://schemas.openxmlformats.org/drawingml/2006/main" xmlns:r="http://schemas.openxmlformats.org/officeDocument/2006/relationships" xmlns:p="http://schemas.openxmlformats.org/presentationml/2006/main">
-  <p:cSld>
-    <p:spTree>
-      <p:nvGrpSpPr>
-        <p:cNvPr id="1" name=""/>
-        <p:cNvGrpSpPr/>
-        <p:nvPr/>
-      </p:nvGrpSpPr>
-      <p:grpSpPr>
-        <a:xfrm>
-          <a:off x="0" y="0"/>
-          <a:ext cx="0" cy="0"/>
-          <a:chOff x="0" y="0"/>
-          <a:chExt cx="0" cy="0"/>
-        </a:xfrm>
-      </p:grpSpPr>
-      <p:grpSp>
-        <p:nvGrpSpPr>
-          <p:cNvPr id="9" name="Group 8">
-            <a:extLst>
-              <a:ext uri="{FF2B5EF4-FFF2-40B4-BE49-F238E27FC236}">
-                <a16:creationId xmlns:a16="http://schemas.microsoft.com/office/drawing/2014/main" id="{2590A2DE-16F5-44B0-79F7-D9518568AB64}"/>
-              </a:ext>
-            </a:extLst>
-          </p:cNvPr>
-          <p:cNvGrpSpPr/>
-          <p:nvPr/>
-        </p:nvGrpSpPr>
-        <p:grpSpPr>
-          <a:xfrm>
-            <a:off x="4468368" y="1625169"/>
-            <a:ext cx="3959748" cy="1566088"/>
-            <a:chOff x="4468368" y="1563624"/>
-            <a:chExt cx="4531517" cy="1792224"/>
-          </a:xfrm>
-        </p:grpSpPr>
-        <p:sp>
-          <p:nvSpPr>
-            <p:cNvPr id="6" name="Rectangle 5">
-              <a:extLst>
-                <a:ext uri="{FF2B5EF4-FFF2-40B4-BE49-F238E27FC236}">
-                  <a16:creationId xmlns:a16="http://schemas.microsoft.com/office/drawing/2014/main" id="{011E5DD6-E9CE-0E04-DAAC-92581C64AEF3}"/>
-                </a:ext>
-              </a:extLst>
-            </p:cNvPr>
-            <p:cNvSpPr/>
-            <p:nvPr/>
-          </p:nvSpPr>
-          <p:spPr>
-            <a:xfrm>
-              <a:off x="4468368" y="2990088"/>
-              <a:ext cx="1627632" cy="365760"/>
-            </a:xfrm>
-            <a:prstGeom prst="rect">
-              <a:avLst/>
-            </a:prstGeom>
-            <a:solidFill>
-              <a:srgbClr val="1A1F71"/>
-            </a:solidFill>
-            <a:ln>
-              <a:noFill/>
-            </a:ln>
-          </p:spPr>
-          <p:style>
-            <a:lnRef idx="2">
-              <a:schemeClr val="accent1">
-                <a:shade val="15000"/>
-              </a:schemeClr>
-            </a:lnRef>
-            <a:fillRef idx="1">
-              <a:schemeClr val="accent1"/>
-            </a:fillRef>
-            <a:effectRef idx="0">
-              <a:schemeClr val="accent1"/>
-            </a:effectRef>
-            <a:fontRef idx="minor">
-              <a:schemeClr val="lt1"/>
-            </a:fontRef>
-          </p:style>
-          <p:txBody>
-            <a:bodyPr rtlCol="0" anchor="ctr"/>
-            <a:lstStyle/>
-            <a:p>
-              <a:pPr algn="ctr"/>
-              <a:endParaRPr lang="en-150"/>
-            </a:p>
-          </p:txBody>
-        </p:sp>
-        <p:sp>
-          <p:nvSpPr>
-            <p:cNvPr id="7" name="Rectangle 6">
-              <a:extLst>
-                <a:ext uri="{FF2B5EF4-FFF2-40B4-BE49-F238E27FC236}">
-                  <a16:creationId xmlns:a16="http://schemas.microsoft.com/office/drawing/2014/main" id="{4E011A50-3FA0-A8E8-8DF5-1CBB2DF4C4FE}"/>
-                </a:ext>
-              </a:extLst>
-            </p:cNvPr>
-            <p:cNvSpPr/>
-            <p:nvPr/>
-          </p:nvSpPr>
-          <p:spPr>
-            <a:xfrm>
-              <a:off x="5920312" y="2276856"/>
-              <a:ext cx="1627632" cy="365760"/>
-            </a:xfrm>
-            <a:prstGeom prst="rect">
-              <a:avLst/>
-            </a:prstGeom>
-            <a:solidFill>
-              <a:srgbClr val="1A1F71"/>
-            </a:solidFill>
-            <a:ln>
-              <a:noFill/>
-            </a:ln>
-          </p:spPr>
-          <p:style>
-            <a:lnRef idx="2">
-              <a:schemeClr val="accent1">
-                <a:shade val="15000"/>
-              </a:schemeClr>
-            </a:lnRef>
-            <a:fillRef idx="1">
-              <a:schemeClr val="accent1"/>
-            </a:fillRef>
-            <a:effectRef idx="0">
-              <a:schemeClr val="accent1"/>
-            </a:effectRef>
-            <a:fontRef idx="minor">
-              <a:schemeClr val="lt1"/>
-            </a:fontRef>
-          </p:style>
-          <p:txBody>
-            <a:bodyPr rtlCol="0" anchor="ctr"/>
-            <a:lstStyle/>
-            <a:p>
-              <a:pPr algn="ctr"/>
-              <a:endParaRPr lang="en-150"/>
-            </a:p>
-          </p:txBody>
-        </p:sp>
-        <p:sp>
-          <p:nvSpPr>
-            <p:cNvPr id="8" name="Rectangle 7">
-              <a:extLst>
-                <a:ext uri="{FF2B5EF4-FFF2-40B4-BE49-F238E27FC236}">
-                  <a16:creationId xmlns:a16="http://schemas.microsoft.com/office/drawing/2014/main" id="{78B4BDD1-236D-438B-09EB-97CA895C3300}"/>
-                </a:ext>
-              </a:extLst>
-            </p:cNvPr>
-            <p:cNvSpPr/>
-            <p:nvPr/>
-          </p:nvSpPr>
-          <p:spPr>
-            <a:xfrm>
-              <a:off x="7372256" y="1563624"/>
-              <a:ext cx="1627629" cy="365760"/>
-            </a:xfrm>
-            <a:prstGeom prst="rect">
-              <a:avLst/>
-            </a:prstGeom>
-            <a:solidFill>
-              <a:srgbClr val="FF6F61"/>
-            </a:solidFill>
-            <a:ln>
-              <a:noFill/>
-            </a:ln>
-          </p:spPr>
-          <p:style>
-            <a:lnRef idx="2">
-              <a:schemeClr val="accent1">
-                <a:shade val="15000"/>
-              </a:schemeClr>
-            </a:lnRef>
-            <a:fillRef idx="1">
-              <a:schemeClr val="accent1"/>
-            </a:fillRef>
-            <a:effectRef idx="0">
-              <a:schemeClr val="accent1"/>
-            </a:effectRef>
-            <a:fontRef idx="minor">
-              <a:schemeClr val="lt1"/>
-            </a:fontRef>
-          </p:style>
-          <p:txBody>
-            <a:bodyPr rtlCol="0" anchor="ctr"/>
-            <a:lstStyle/>
-            <a:p>
-              <a:pPr algn="ctr"/>
-              <a:endParaRPr lang="en-150"/>
-            </a:p>
-          </p:txBody>
-        </p:sp>
-      </p:grpSp>
-      <p:sp>
-        <p:nvSpPr>
-          <p:cNvPr id="2" name="TextBox 1">
-            <a:extLst>
-              <a:ext uri="{FF2B5EF4-FFF2-40B4-BE49-F238E27FC236}">
-                <a16:creationId xmlns:a16="http://schemas.microsoft.com/office/drawing/2014/main" id="{5DF106CF-89D1-049C-3FD4-88578CB84BF1}"/>
-              </a:ext>
-            </a:extLst>
-          </p:cNvPr>
-          <p:cNvSpPr txBox="1"/>
-          <p:nvPr/>
-        </p:nvSpPr>
-        <p:spPr>
-          <a:xfrm>
-            <a:off x="4344360" y="3218689"/>
-            <a:ext cx="4253087" cy="1200329"/>
-          </a:xfrm>
-          <a:prstGeom prst="rect">
-            <a:avLst/>
-          </a:prstGeom>
-          <a:noFill/>
-        </p:spPr>
-        <p:txBody>
-          <a:bodyPr wrap="none" rtlCol="0">
-            <a:spAutoFit/>
-          </a:bodyPr>
-          <a:lstStyle/>
-          <a:p>
-            <a:r>
-              <a:rPr lang="en-US" sz="7200" dirty="0">
-                <a:solidFill>
-                  <a:srgbClr val="1A1F71"/>
-                </a:solidFill>
-                <a:latin typeface="Aafia" pitchFamily="50" charset="0"/>
-              </a:rPr>
-              <a:t>LaDe</a:t>
-            </a:r>
-            <a:r>
-              <a:rPr lang="en-US" sz="7200" dirty="0">
-                <a:solidFill>
-                  <a:srgbClr val="FF6F61"/>
-                </a:solidFill>
-                <a:latin typeface="Aafia" pitchFamily="50" charset="0"/>
-              </a:rPr>
-              <a:t>RR</a:t>
-            </a:r>
-          </a:p>
-        </p:txBody>
-      </p:sp>
-    </p:spTree>
-    <p:extLst>
-      <p:ext uri="{BB962C8B-B14F-4D97-AF65-F5344CB8AC3E}">
-        <p14:creationId xmlns:p14="http://schemas.microsoft.com/office/powerpoint/2010/main" val="2663385008"/>
       </p:ext>
     </p:extLst>
   </p:cSld>

</xml_diff>

<commit_message>
updated logo and readme
</commit_message>
<xml_diff>
--- a/resources/base logo.pptx
+++ b/resources/base logo.pptx
@@ -9,7 +9,7 @@
   </p:notesMasterIdLst>
   <p:sldIdLst>
     <p:sldId id="291" r:id="rId2"/>
-    <p:sldId id="292" r:id="rId3"/>
+    <p:sldId id="293" r:id="rId3"/>
     <p:sldId id="286" r:id="rId4"/>
     <p:sldId id="288" r:id="rId5"/>
     <p:sldId id="289" r:id="rId6"/>
@@ -121,7 +121,7 @@
   <p:extLst>
     <p:ext uri="{EFAFB233-063F-42B5-8137-9DF3F51BA10A}">
       <p15:sldGuideLst xmlns:p15="http://schemas.microsoft.com/office/powerpoint/2012/main">
-        <p15:guide id="1" orient="horz" pos="2364" userDrawn="1">
+        <p15:guide id="1" orient="horz" pos="1865" userDrawn="1">
           <p15:clr>
             <a:srgbClr val="A4A3A4"/>
           </p15:clr>
@@ -142,6 +142,21 @@
           </p15:clr>
         </p15:guide>
         <p15:guide id="6" pos="6879" userDrawn="1">
+          <p15:clr>
+            <a:srgbClr val="A4A3A4"/>
+          </p15:clr>
+        </p15:guide>
+        <p15:guide id="7" orient="horz" pos="1911" userDrawn="1">
+          <p15:clr>
+            <a:srgbClr val="A4A3A4"/>
+          </p15:clr>
+        </p15:guide>
+        <p15:guide id="8" orient="horz" pos="2296" userDrawn="1">
+          <p15:clr>
+            <a:srgbClr val="A4A3A4"/>
+          </p15:clr>
+        </p15:guide>
+        <p15:guide id="9" orient="horz" pos="2341" userDrawn="1">
           <p15:clr>
             <a:srgbClr val="A4A3A4"/>
           </p15:clr>
@@ -234,7 +249,7 @@
           <a:p>
             <a:fld id="{DC0890D7-75A3-4AFD-AFCE-7BC66DB681C5}" type="datetimeFigureOut">
               <a:rPr lang="en-150" smtClean="0"/>
-              <a:t>28/01/2025</a:t>
+              <a:t>10/02/2025</a:t>
             </a:fld>
             <a:endParaRPr lang="en-150"/>
           </a:p>
@@ -651,7 +666,7 @@
           <a:p>
             <a:fld id="{97A7BB66-1ADB-47C6-8EE2-F72BFA79F05A}" type="datetimeFigureOut">
               <a:rPr lang="en-150" smtClean="0"/>
-              <a:t>28/01/2025</a:t>
+              <a:t>10/02/2025</a:t>
             </a:fld>
             <a:endParaRPr lang="en-150"/>
           </a:p>
@@ -867,7 +882,7 @@
           <a:p>
             <a:fld id="{97A7BB66-1ADB-47C6-8EE2-F72BFA79F05A}" type="datetimeFigureOut">
               <a:rPr lang="en-150" smtClean="0"/>
-              <a:t>28/01/2025</a:t>
+              <a:t>10/02/2025</a:t>
             </a:fld>
             <a:endParaRPr lang="en-150"/>
           </a:p>
@@ -1077,7 +1092,7 @@
           <a:p>
             <a:fld id="{97A7BB66-1ADB-47C6-8EE2-F72BFA79F05A}" type="datetimeFigureOut">
               <a:rPr lang="en-150" smtClean="0"/>
-              <a:t>28/01/2025</a:t>
+              <a:t>10/02/2025</a:t>
             </a:fld>
             <a:endParaRPr lang="en-150"/>
           </a:p>
@@ -1277,7 +1292,7 @@
           <a:p>
             <a:fld id="{97A7BB66-1ADB-47C6-8EE2-F72BFA79F05A}" type="datetimeFigureOut">
               <a:rPr lang="en-150" smtClean="0"/>
-              <a:t>28/01/2025</a:t>
+              <a:t>10/02/2025</a:t>
             </a:fld>
             <a:endParaRPr lang="en-150"/>
           </a:p>
@@ -1569,7 +1584,7 @@
           <a:p>
             <a:fld id="{97A7BB66-1ADB-47C6-8EE2-F72BFA79F05A}" type="datetimeFigureOut">
               <a:rPr lang="en-150" smtClean="0"/>
-              <a:t>28/01/2025</a:t>
+              <a:t>10/02/2025</a:t>
             </a:fld>
             <a:endParaRPr lang="en-150"/>
           </a:p>
@@ -1837,7 +1852,7 @@
           <a:p>
             <a:fld id="{97A7BB66-1ADB-47C6-8EE2-F72BFA79F05A}" type="datetimeFigureOut">
               <a:rPr lang="en-150" smtClean="0"/>
-              <a:t>28/01/2025</a:t>
+              <a:t>10/02/2025</a:t>
             </a:fld>
             <a:endParaRPr lang="en-150"/>
           </a:p>
@@ -2252,7 +2267,7 @@
           <a:p>
             <a:fld id="{97A7BB66-1ADB-47C6-8EE2-F72BFA79F05A}" type="datetimeFigureOut">
               <a:rPr lang="en-150" smtClean="0"/>
-              <a:t>28/01/2025</a:t>
+              <a:t>10/02/2025</a:t>
             </a:fld>
             <a:endParaRPr lang="en-150"/>
           </a:p>
@@ -2394,7 +2409,7 @@
           <a:p>
             <a:fld id="{97A7BB66-1ADB-47C6-8EE2-F72BFA79F05A}" type="datetimeFigureOut">
               <a:rPr lang="en-150" smtClean="0"/>
-              <a:t>28/01/2025</a:t>
+              <a:t>10/02/2025</a:t>
             </a:fld>
             <a:endParaRPr lang="en-150"/>
           </a:p>
@@ -2507,7 +2522,7 @@
           <a:p>
             <a:fld id="{97A7BB66-1ADB-47C6-8EE2-F72BFA79F05A}" type="datetimeFigureOut">
               <a:rPr lang="en-150" smtClean="0"/>
-              <a:t>28/01/2025</a:t>
+              <a:t>10/02/2025</a:t>
             </a:fld>
             <a:endParaRPr lang="en-150"/>
           </a:p>
@@ -2820,7 +2835,7 @@
           <a:p>
             <a:fld id="{97A7BB66-1ADB-47C6-8EE2-F72BFA79F05A}" type="datetimeFigureOut">
               <a:rPr lang="en-150" smtClean="0"/>
-              <a:t>28/01/2025</a:t>
+              <a:t>10/02/2025</a:t>
             </a:fld>
             <a:endParaRPr lang="en-150"/>
           </a:p>
@@ -3109,7 +3124,7 @@
           <a:p>
             <a:fld id="{97A7BB66-1ADB-47C6-8EE2-F72BFA79F05A}" type="datetimeFigureOut">
               <a:rPr lang="en-150" smtClean="0"/>
-              <a:t>28/01/2025</a:t>
+              <a:t>10/02/2025</a:t>
             </a:fld>
             <a:endParaRPr lang="en-150"/>
           </a:p>
@@ -3351,7 +3366,7 @@
           <a:p>
             <a:fld id="{97A7BB66-1ADB-47C6-8EE2-F72BFA79F05A}" type="datetimeFigureOut">
               <a:rPr lang="en-150" smtClean="0"/>
-              <a:t>28/01/2025</a:t>
+              <a:t>10/02/2025</a:t>
             </a:fld>
             <a:endParaRPr lang="en-150"/>
           </a:p>
@@ -5217,7 +5232,7 @@
         <p:cNvPr id="1" name="">
           <a:extLst>
             <a:ext uri="{FF2B5EF4-FFF2-40B4-BE49-F238E27FC236}">
-              <a16:creationId xmlns:a16="http://schemas.microsoft.com/office/drawing/2014/main" id="{17A2AECE-803C-C14D-92EA-045167590D42}"/>
+              <a16:creationId xmlns:a16="http://schemas.microsoft.com/office/drawing/2014/main" id="{6D904611-22B7-C897-FE07-3BC9A8278594}"/>
             </a:ext>
           </a:extLst>
         </p:cNvPr>
@@ -5237,7 +5252,7 @@
           <p:cNvPr id="12" name="Rectangle 11">
             <a:extLst>
               <a:ext uri="{FF2B5EF4-FFF2-40B4-BE49-F238E27FC236}">
-                <a16:creationId xmlns:a16="http://schemas.microsoft.com/office/drawing/2014/main" id="{CC1452E2-4D60-D378-BB0A-32DCEAC90159}"/>
+                <a16:creationId xmlns:a16="http://schemas.microsoft.com/office/drawing/2014/main" id="{1E841810-4848-ED1E-1246-A0F736CB5297}"/>
               </a:ext>
             </a:extLst>
           </p:cNvPr>
@@ -5246,7 +5261,7 @@
         </p:nvSpPr>
         <p:spPr>
           <a:xfrm>
-            <a:off x="6734175" y="2759041"/>
+            <a:off x="6734175" y="2816191"/>
             <a:ext cx="1223963" cy="149432"/>
           </a:xfrm>
           <a:prstGeom prst="rect">
@@ -5301,7 +5316,7 @@
           <p:cNvPr id="13" name="Rectangle 12">
             <a:extLst>
               <a:ext uri="{FF2B5EF4-FFF2-40B4-BE49-F238E27FC236}">
-                <a16:creationId xmlns:a16="http://schemas.microsoft.com/office/drawing/2014/main" id="{51D456FA-1BB7-2DC0-1C94-925D5EB7A450}"/>
+                <a16:creationId xmlns:a16="http://schemas.microsoft.com/office/drawing/2014/main" id="{297E3C51-792E-71C4-3609-9989C2BF0F77}"/>
               </a:ext>
             </a:extLst>
           </p:cNvPr>
@@ -5310,7 +5325,7 @@
         </p:nvSpPr>
         <p:spPr>
           <a:xfrm>
-            <a:off x="7958138" y="2601989"/>
+            <a:off x="7958138" y="2659139"/>
             <a:ext cx="1368425" cy="149432"/>
           </a:xfrm>
           <a:prstGeom prst="rect">
@@ -5365,7 +5380,7 @@
           <p:cNvPr id="14" name="Rectangle 13">
             <a:extLst>
               <a:ext uri="{FF2B5EF4-FFF2-40B4-BE49-F238E27FC236}">
-                <a16:creationId xmlns:a16="http://schemas.microsoft.com/office/drawing/2014/main" id="{D3BE7271-8349-F22F-6698-DE676C5590AF}"/>
+                <a16:creationId xmlns:a16="http://schemas.microsoft.com/office/drawing/2014/main" id="{DA72054A-4C5B-7E2D-91D3-4A22A50AFE79}"/>
               </a:ext>
             </a:extLst>
           </p:cNvPr>
@@ -5374,7 +5389,7 @@
         </p:nvSpPr>
         <p:spPr>
           <a:xfrm>
-            <a:off x="9326564" y="2444937"/>
+            <a:off x="9326564" y="2502087"/>
             <a:ext cx="1377950" cy="149432"/>
           </a:xfrm>
           <a:prstGeom prst="rect">
@@ -5437,7 +5452,7 @@
           <p:cNvPr id="15" name="TextBox 14">
             <a:extLst>
               <a:ext uri="{FF2B5EF4-FFF2-40B4-BE49-F238E27FC236}">
-                <a16:creationId xmlns:a16="http://schemas.microsoft.com/office/drawing/2014/main" id="{3505A1EF-63A0-4328-4BA7-163C3DDE54F0}"/>
+                <a16:creationId xmlns:a16="http://schemas.microsoft.com/office/drawing/2014/main" id="{83D28326-DFEC-DA4A-7F24-5593A0F2707D}"/>
               </a:ext>
             </a:extLst>
           </p:cNvPr>
@@ -5515,7 +5530,7 @@
           <p:cNvPr id="19" name="TextBox 18">
             <a:extLst>
               <a:ext uri="{FF2B5EF4-FFF2-40B4-BE49-F238E27FC236}">
-                <a16:creationId xmlns:a16="http://schemas.microsoft.com/office/drawing/2014/main" id="{DC54A8A1-F903-CEBA-6CFE-33F719E328FD}"/>
+                <a16:creationId xmlns:a16="http://schemas.microsoft.com/office/drawing/2014/main" id="{E5ECF1B9-269C-2F29-E619-FC104AAEEE14}"/>
               </a:ext>
             </a:extLst>
           </p:cNvPr>
@@ -5572,10 +5587,338 @@
           </a:p>
         </p:txBody>
       </p:sp>
+      <p:grpSp>
+        <p:nvGrpSpPr>
+          <p:cNvPr id="7" name="Group 6">
+            <a:extLst>
+              <a:ext uri="{FF2B5EF4-FFF2-40B4-BE49-F238E27FC236}">
+                <a16:creationId xmlns:a16="http://schemas.microsoft.com/office/drawing/2014/main" id="{5CA38074-ED14-FB0B-081A-0AEAA26EC8BE}"/>
+              </a:ext>
+            </a:extLst>
+          </p:cNvPr>
+          <p:cNvGrpSpPr/>
+          <p:nvPr/>
+        </p:nvGrpSpPr>
+        <p:grpSpPr>
+          <a:xfrm>
+            <a:off x="769938" y="583285"/>
+            <a:ext cx="4253087" cy="1553375"/>
+            <a:chOff x="587089" y="854262"/>
+            <a:chExt cx="4253087" cy="1553375"/>
+          </a:xfrm>
+        </p:grpSpPr>
+        <p:sp>
+          <p:nvSpPr>
+            <p:cNvPr id="8" name="Rectangle 7">
+              <a:extLst>
+                <a:ext uri="{FF2B5EF4-FFF2-40B4-BE49-F238E27FC236}">
+                  <a16:creationId xmlns:a16="http://schemas.microsoft.com/office/drawing/2014/main" id="{583C051B-A39B-AC04-76B0-DC200FAC2D8B}"/>
+                </a:ext>
+              </a:extLst>
+            </p:cNvPr>
+            <p:cNvSpPr/>
+            <p:nvPr/>
+          </p:nvSpPr>
+          <p:spPr>
+            <a:xfrm>
+              <a:off x="714375" y="1168366"/>
+              <a:ext cx="1223963" cy="149432"/>
+            </a:xfrm>
+            <a:prstGeom prst="rect">
+              <a:avLst/>
+            </a:prstGeom>
+            <a:solidFill>
+              <a:srgbClr val="1A1F71"/>
+            </a:solidFill>
+            <a:ln w="3175">
+              <a:noFill/>
+            </a:ln>
+            <a:effectLst>
+              <a:outerShdw blurRad="57785" dist="33020" dir="3180000" algn="ctr">
+                <a:srgbClr val="000000">
+                  <a:alpha val="30000"/>
+                </a:srgbClr>
+              </a:outerShdw>
+            </a:effectLst>
+          </p:spPr>
+          <p:style>
+            <a:lnRef idx="2">
+              <a:schemeClr val="accent1">
+                <a:shade val="15000"/>
+              </a:schemeClr>
+            </a:lnRef>
+            <a:fillRef idx="1">
+              <a:schemeClr val="accent1"/>
+            </a:fillRef>
+            <a:effectRef idx="0">
+              <a:schemeClr val="accent1"/>
+            </a:effectRef>
+            <a:fontRef idx="minor">
+              <a:schemeClr val="lt1"/>
+            </a:fontRef>
+          </p:style>
+          <p:txBody>
+            <a:bodyPr rtlCol="0" anchor="ctr"/>
+            <a:lstStyle/>
+            <a:p>
+              <a:pPr algn="ctr"/>
+              <a:endParaRPr lang="en-150">
+                <a:ln w="3175">
+                  <a:solidFill>
+                    <a:schemeClr val="bg1">
+                      <a:lumMod val="95000"/>
+                    </a:schemeClr>
+                  </a:solidFill>
+                </a:ln>
+                <a:solidFill>
+                  <a:srgbClr val="1A1F71"/>
+                </a:solidFill>
+              </a:endParaRPr>
+            </a:p>
+          </p:txBody>
+        </p:sp>
+        <p:sp>
+          <p:nvSpPr>
+            <p:cNvPr id="9" name="Rectangle 8">
+              <a:extLst>
+                <a:ext uri="{FF2B5EF4-FFF2-40B4-BE49-F238E27FC236}">
+                  <a16:creationId xmlns:a16="http://schemas.microsoft.com/office/drawing/2014/main" id="{4A100315-569F-0257-8A1C-6DABADA772E4}"/>
+                </a:ext>
+              </a:extLst>
+            </p:cNvPr>
+            <p:cNvSpPr/>
+            <p:nvPr/>
+          </p:nvSpPr>
+          <p:spPr>
+            <a:xfrm>
+              <a:off x="1938338" y="1011314"/>
+              <a:ext cx="1368425" cy="149432"/>
+            </a:xfrm>
+            <a:prstGeom prst="rect">
+              <a:avLst/>
+            </a:prstGeom>
+            <a:solidFill>
+              <a:srgbClr val="1A1F71"/>
+            </a:solidFill>
+            <a:ln w="3175">
+              <a:noFill/>
+            </a:ln>
+            <a:effectLst>
+              <a:outerShdw blurRad="57785" dist="33020" dir="3180000" algn="ctr">
+                <a:srgbClr val="000000">
+                  <a:alpha val="30000"/>
+                </a:srgbClr>
+              </a:outerShdw>
+            </a:effectLst>
+          </p:spPr>
+          <p:style>
+            <a:lnRef idx="2">
+              <a:schemeClr val="accent1">
+                <a:shade val="15000"/>
+              </a:schemeClr>
+            </a:lnRef>
+            <a:fillRef idx="1">
+              <a:schemeClr val="accent1"/>
+            </a:fillRef>
+            <a:effectRef idx="0">
+              <a:schemeClr val="accent1"/>
+            </a:effectRef>
+            <a:fontRef idx="minor">
+              <a:schemeClr val="lt1"/>
+            </a:fontRef>
+          </p:style>
+          <p:txBody>
+            <a:bodyPr rtlCol="0" anchor="ctr"/>
+            <a:lstStyle/>
+            <a:p>
+              <a:pPr algn="ctr"/>
+              <a:endParaRPr lang="en-150">
+                <a:ln w="3175">
+                  <a:solidFill>
+                    <a:schemeClr val="bg1">
+                      <a:lumMod val="95000"/>
+                    </a:schemeClr>
+                  </a:solidFill>
+                </a:ln>
+                <a:solidFill>
+                  <a:srgbClr val="1A1F71"/>
+                </a:solidFill>
+              </a:endParaRPr>
+            </a:p>
+          </p:txBody>
+        </p:sp>
+        <p:sp>
+          <p:nvSpPr>
+            <p:cNvPr id="10" name="Rectangle 9">
+              <a:extLst>
+                <a:ext uri="{FF2B5EF4-FFF2-40B4-BE49-F238E27FC236}">
+                  <a16:creationId xmlns:a16="http://schemas.microsoft.com/office/drawing/2014/main" id="{FB32A31A-FE84-27AE-9FA5-BD93B1A599A0}"/>
+                </a:ext>
+              </a:extLst>
+            </p:cNvPr>
+            <p:cNvSpPr/>
+            <p:nvPr/>
+          </p:nvSpPr>
+          <p:spPr>
+            <a:xfrm>
+              <a:off x="3306764" y="854262"/>
+              <a:ext cx="1377950" cy="149432"/>
+            </a:xfrm>
+            <a:prstGeom prst="rect">
+              <a:avLst/>
+            </a:prstGeom>
+            <a:gradFill flip="none" rotWithShape="1">
+              <a:gsLst>
+                <a:gs pos="0">
+                  <a:srgbClr val="FFD700"/>
+                </a:gs>
+                <a:gs pos="78000">
+                  <a:srgbClr val="FFD700"/>
+                </a:gs>
+                <a:gs pos="100000">
+                  <a:schemeClr val="bg1"/>
+                </a:gs>
+              </a:gsLst>
+              <a:lin ang="18900000" scaled="1"/>
+              <a:tileRect/>
+            </a:gradFill>
+            <a:ln w="3175">
+              <a:noFill/>
+            </a:ln>
+            <a:effectLst>
+              <a:outerShdw blurRad="57785" dist="33020" dir="3180000" algn="ctr">
+                <a:srgbClr val="000000">
+                  <a:alpha val="30000"/>
+                </a:srgbClr>
+              </a:outerShdw>
+            </a:effectLst>
+          </p:spPr>
+          <p:style>
+            <a:lnRef idx="2">
+              <a:schemeClr val="accent1">
+                <a:shade val="15000"/>
+              </a:schemeClr>
+            </a:lnRef>
+            <a:fillRef idx="1">
+              <a:schemeClr val="accent1"/>
+            </a:fillRef>
+            <a:effectRef idx="0">
+              <a:schemeClr val="accent1"/>
+            </a:effectRef>
+            <a:fontRef idx="minor">
+              <a:schemeClr val="lt1"/>
+            </a:fontRef>
+          </p:style>
+          <p:txBody>
+            <a:bodyPr rtlCol="0" anchor="ctr"/>
+            <a:lstStyle/>
+            <a:p>
+              <a:pPr algn="ctr"/>
+              <a:endParaRPr lang="en-150">
+                <a:ln w="3175">
+                  <a:solidFill>
+                    <a:schemeClr val="bg1">
+                      <a:lumMod val="95000"/>
+                    </a:schemeClr>
+                  </a:solidFill>
+                </a:ln>
+              </a:endParaRPr>
+            </a:p>
+          </p:txBody>
+        </p:sp>
+        <p:sp>
+          <p:nvSpPr>
+            <p:cNvPr id="11" name="TextBox 10">
+              <a:extLst>
+                <a:ext uri="{FF2B5EF4-FFF2-40B4-BE49-F238E27FC236}">
+                  <a16:creationId xmlns:a16="http://schemas.microsoft.com/office/drawing/2014/main" id="{32F225EA-5826-AB82-F3AE-714C3CD68F5D}"/>
+                </a:ext>
+              </a:extLst>
+            </p:cNvPr>
+            <p:cNvSpPr txBox="1"/>
+            <p:nvPr/>
+          </p:nvSpPr>
+          <p:spPr>
+            <a:xfrm>
+              <a:off x="587089" y="1207308"/>
+              <a:ext cx="4253087" cy="1200329"/>
+            </a:xfrm>
+            <a:prstGeom prst="rect">
+              <a:avLst/>
+            </a:prstGeom>
+            <a:noFill/>
+            <a:ln>
+              <a:noFill/>
+            </a:ln>
+            <a:effectLst>
+              <a:outerShdw blurRad="57785" dist="33020" dir="3180000" algn="ctr">
+                <a:srgbClr val="000000">
+                  <a:alpha val="30000"/>
+                </a:srgbClr>
+              </a:outerShdw>
+            </a:effectLst>
+          </p:spPr>
+          <p:txBody>
+            <a:bodyPr wrap="none" rtlCol="0">
+              <a:spAutoFit/>
+              <a:sp3d extrusionH="38100">
+                <a:bevelT w="38100" h="38100"/>
+              </a:sp3d>
+            </a:bodyPr>
+            <a:lstStyle/>
+            <a:p>
+              <a:r>
+                <a:rPr lang="en-US" sz="7200" dirty="0">
+                  <a:ln w="3175">
+                    <a:solidFill>
+                      <a:schemeClr val="bg1">
+                        <a:lumMod val="95000"/>
+                      </a:schemeClr>
+                    </a:solidFill>
+                  </a:ln>
+                  <a:solidFill>
+                    <a:srgbClr val="1A1F71"/>
+                  </a:solidFill>
+                  <a:latin typeface="Aafia" pitchFamily="50" charset="0"/>
+                </a:rPr>
+                <a:t>LaDe</a:t>
+              </a:r>
+              <a:r>
+                <a:rPr lang="en-US" sz="7200" dirty="0">
+                  <a:ln w="3175">
+                    <a:solidFill>
+                      <a:schemeClr val="bg1">
+                        <a:lumMod val="95000"/>
+                      </a:schemeClr>
+                    </a:solidFill>
+                  </a:ln>
+                  <a:gradFill flip="none" rotWithShape="1">
+                    <a:gsLst>
+                      <a:gs pos="80000">
+                        <a:srgbClr val="FFD700"/>
+                      </a:gs>
+                      <a:gs pos="0">
+                        <a:srgbClr val="FFD700"/>
+                      </a:gs>
+                      <a:gs pos="100000">
+                        <a:schemeClr val="bg1"/>
+                      </a:gs>
+                    </a:gsLst>
+                    <a:lin ang="18900000" scaled="1"/>
+                    <a:tileRect/>
+                  </a:gradFill>
+                  <a:latin typeface="Aafia" pitchFamily="50" charset="0"/>
+                </a:rPr>
+                <a:t>RR</a:t>
+              </a:r>
+            </a:p>
+          </p:txBody>
+        </p:sp>
+      </p:grpSp>
     </p:spTree>
     <p:extLst>
       <p:ext uri="{BB962C8B-B14F-4D97-AF65-F5344CB8AC3E}">
-        <p14:creationId xmlns:p14="http://schemas.microsoft.com/office/powerpoint/2010/main" val="1047741798"/>
+        <p14:creationId xmlns:p14="http://schemas.microsoft.com/office/powerpoint/2010/main" val="1312158596"/>
       </p:ext>
     </p:extLst>
   </p:cSld>

</xml_diff>

<commit_message>
updated vocab and page
</commit_message>
<xml_diff>
--- a/resources/base logo.pptx
+++ b/resources/base logo.pptx
@@ -5,7 +5,7 @@
     <p:sldMasterId id="2147483648" r:id="rId1"/>
   </p:sldMasterIdLst>
   <p:notesMasterIdLst>
-    <p:notesMasterId r:id="rId14"/>
+    <p:notesMasterId r:id="rId15"/>
   </p:notesMasterIdLst>
   <p:sldIdLst>
     <p:sldId id="291" r:id="rId2"/>
@@ -20,6 +20,7 @@
     <p:sldId id="283" r:id="rId11"/>
     <p:sldId id="284" r:id="rId12"/>
     <p:sldId id="280" r:id="rId13"/>
+    <p:sldId id="294" r:id="rId14"/>
   </p:sldIdLst>
   <p:sldSz cx="12192000" cy="6858000"/>
   <p:notesSz cx="6858000" cy="9144000"/>
@@ -121,42 +122,17 @@
   <p:extLst>
     <p:ext uri="{EFAFB233-063F-42B5-8137-9DF3F51BA10A}">
       <p15:sldGuideLst xmlns:p15="http://schemas.microsoft.com/office/powerpoint/2012/main">
-        <p15:guide id="1" orient="horz" pos="1865" userDrawn="1">
-          <p15:clr>
-            <a:srgbClr val="A4A3A4"/>
-          </p15:clr>
-        </p15:guide>
         <p15:guide id="3" pos="6743" userDrawn="1">
           <p15:clr>
             <a:srgbClr val="A4A3A4"/>
           </p15:clr>
         </p15:guide>
-        <p15:guide id="4" pos="4248" userDrawn="1">
-          <p15:clr>
-            <a:srgbClr val="A4A3A4"/>
-          </p15:clr>
-        </p15:guide>
-        <p15:guide id="5" pos="2910" userDrawn="1">
+        <p15:guide id="4" pos="3840" userDrawn="1">
           <p15:clr>
             <a:srgbClr val="A4A3A4"/>
           </p15:clr>
         </p15:guide>
         <p15:guide id="6" pos="6879" userDrawn="1">
-          <p15:clr>
-            <a:srgbClr val="A4A3A4"/>
-          </p15:clr>
-        </p15:guide>
-        <p15:guide id="7" orient="horz" pos="1911" userDrawn="1">
-          <p15:clr>
-            <a:srgbClr val="A4A3A4"/>
-          </p15:clr>
-        </p15:guide>
-        <p15:guide id="8" orient="horz" pos="2296" userDrawn="1">
-          <p15:clr>
-            <a:srgbClr val="A4A3A4"/>
-          </p15:clr>
-        </p15:guide>
-        <p15:guide id="9" orient="horz" pos="2341" userDrawn="1">
           <p15:clr>
             <a:srgbClr val="A4A3A4"/>
           </p15:clr>
@@ -249,7 +225,7 @@
           <a:p>
             <a:fld id="{DC0890D7-75A3-4AFD-AFCE-7BC66DB681C5}" type="datetimeFigureOut">
               <a:rPr lang="en-150" smtClean="0"/>
-              <a:t>10/02/2025</a:t>
+              <a:t>12/03/2025</a:t>
             </a:fld>
             <a:endParaRPr lang="en-150"/>
           </a:p>
@@ -666,7 +642,7 @@
           <a:p>
             <a:fld id="{97A7BB66-1ADB-47C6-8EE2-F72BFA79F05A}" type="datetimeFigureOut">
               <a:rPr lang="en-150" smtClean="0"/>
-              <a:t>10/02/2025</a:t>
+              <a:t>12/03/2025</a:t>
             </a:fld>
             <a:endParaRPr lang="en-150"/>
           </a:p>
@@ -882,7 +858,7 @@
           <a:p>
             <a:fld id="{97A7BB66-1ADB-47C6-8EE2-F72BFA79F05A}" type="datetimeFigureOut">
               <a:rPr lang="en-150" smtClean="0"/>
-              <a:t>10/02/2025</a:t>
+              <a:t>12/03/2025</a:t>
             </a:fld>
             <a:endParaRPr lang="en-150"/>
           </a:p>
@@ -1092,7 +1068,7 @@
           <a:p>
             <a:fld id="{97A7BB66-1ADB-47C6-8EE2-F72BFA79F05A}" type="datetimeFigureOut">
               <a:rPr lang="en-150" smtClean="0"/>
-              <a:t>10/02/2025</a:t>
+              <a:t>12/03/2025</a:t>
             </a:fld>
             <a:endParaRPr lang="en-150"/>
           </a:p>
@@ -1292,7 +1268,7 @@
           <a:p>
             <a:fld id="{97A7BB66-1ADB-47C6-8EE2-F72BFA79F05A}" type="datetimeFigureOut">
               <a:rPr lang="en-150" smtClean="0"/>
-              <a:t>10/02/2025</a:t>
+              <a:t>12/03/2025</a:t>
             </a:fld>
             <a:endParaRPr lang="en-150"/>
           </a:p>
@@ -1584,7 +1560,7 @@
           <a:p>
             <a:fld id="{97A7BB66-1ADB-47C6-8EE2-F72BFA79F05A}" type="datetimeFigureOut">
               <a:rPr lang="en-150" smtClean="0"/>
-              <a:t>10/02/2025</a:t>
+              <a:t>12/03/2025</a:t>
             </a:fld>
             <a:endParaRPr lang="en-150"/>
           </a:p>
@@ -1852,7 +1828,7 @@
           <a:p>
             <a:fld id="{97A7BB66-1ADB-47C6-8EE2-F72BFA79F05A}" type="datetimeFigureOut">
               <a:rPr lang="en-150" smtClean="0"/>
-              <a:t>10/02/2025</a:t>
+              <a:t>12/03/2025</a:t>
             </a:fld>
             <a:endParaRPr lang="en-150"/>
           </a:p>
@@ -2267,7 +2243,7 @@
           <a:p>
             <a:fld id="{97A7BB66-1ADB-47C6-8EE2-F72BFA79F05A}" type="datetimeFigureOut">
               <a:rPr lang="en-150" smtClean="0"/>
-              <a:t>10/02/2025</a:t>
+              <a:t>12/03/2025</a:t>
             </a:fld>
             <a:endParaRPr lang="en-150"/>
           </a:p>
@@ -2409,7 +2385,7 @@
           <a:p>
             <a:fld id="{97A7BB66-1ADB-47C6-8EE2-F72BFA79F05A}" type="datetimeFigureOut">
               <a:rPr lang="en-150" smtClean="0"/>
-              <a:t>10/02/2025</a:t>
+              <a:t>12/03/2025</a:t>
             </a:fld>
             <a:endParaRPr lang="en-150"/>
           </a:p>
@@ -2522,7 +2498,7 @@
           <a:p>
             <a:fld id="{97A7BB66-1ADB-47C6-8EE2-F72BFA79F05A}" type="datetimeFigureOut">
               <a:rPr lang="en-150" smtClean="0"/>
-              <a:t>10/02/2025</a:t>
+              <a:t>12/03/2025</a:t>
             </a:fld>
             <a:endParaRPr lang="en-150"/>
           </a:p>
@@ -2835,7 +2811,7 @@
           <a:p>
             <a:fld id="{97A7BB66-1ADB-47C6-8EE2-F72BFA79F05A}" type="datetimeFigureOut">
               <a:rPr lang="en-150" smtClean="0"/>
-              <a:t>10/02/2025</a:t>
+              <a:t>12/03/2025</a:t>
             </a:fld>
             <a:endParaRPr lang="en-150"/>
           </a:p>
@@ -3124,7 +3100,7 @@
           <a:p>
             <a:fld id="{97A7BB66-1ADB-47C6-8EE2-F72BFA79F05A}" type="datetimeFigureOut">
               <a:rPr lang="en-150" smtClean="0"/>
-              <a:t>10/02/2025</a:t>
+              <a:t>12/03/2025</a:t>
             </a:fld>
             <a:endParaRPr lang="en-150"/>
           </a:p>
@@ -3366,7 +3342,7 @@
           <a:p>
             <a:fld id="{97A7BB66-1ADB-47C6-8EE2-F72BFA79F05A}" type="datetimeFigureOut">
               <a:rPr lang="en-150" smtClean="0"/>
-              <a:t>10/02/2025</a:t>
+              <a:t>12/03/2025</a:t>
             </a:fld>
             <a:endParaRPr lang="en-150"/>
           </a:p>
@@ -5215,6 +5191,173 @@
     <p:extLst>
       <p:ext uri="{BB962C8B-B14F-4D97-AF65-F5344CB8AC3E}">
         <p14:creationId xmlns:p14="http://schemas.microsoft.com/office/powerpoint/2010/main" val="1298690516"/>
+      </p:ext>
+    </p:extLst>
+  </p:cSld>
+  <p:clrMapOvr>
+    <a:masterClrMapping/>
+  </p:clrMapOvr>
+</p:sld>
+</file>
+
+<file path=ppt/slides/slide13.xml><?xml version="1.0" encoding="utf-8"?>
+<p:sld xmlns:a="http://schemas.openxmlformats.org/drawingml/2006/main" xmlns:r="http://schemas.openxmlformats.org/officeDocument/2006/relationships" xmlns:p="http://schemas.openxmlformats.org/presentationml/2006/main">
+  <p:cSld>
+    <p:spTree>
+      <p:nvGrpSpPr>
+        <p:cNvPr id="1" name=""/>
+        <p:cNvGrpSpPr/>
+        <p:nvPr/>
+      </p:nvGrpSpPr>
+      <p:grpSpPr>
+        <a:xfrm>
+          <a:off x="0" y="0"/>
+          <a:ext cx="0" cy="0"/>
+          <a:chOff x="0" y="0"/>
+          <a:chExt cx="0" cy="0"/>
+        </a:xfrm>
+      </p:grpSpPr>
+      <p:pic>
+        <p:nvPicPr>
+          <p:cNvPr id="5" name="Picture 4" descr="A white card with black text and black text&#10;&#10;AI-generated content may be incorrect.">
+            <a:extLst>
+              <a:ext uri="{FF2B5EF4-FFF2-40B4-BE49-F238E27FC236}">
+                <a16:creationId xmlns:a16="http://schemas.microsoft.com/office/drawing/2014/main" id="{1E7BEED1-CF56-A13F-35EB-36FFC9A54899}"/>
+              </a:ext>
+            </a:extLst>
+          </p:cNvPr>
+          <p:cNvPicPr>
+            <a:picLocks noChangeAspect="1"/>
+          </p:cNvPicPr>
+          <p:nvPr/>
+        </p:nvPicPr>
+        <p:blipFill>
+          <a:blip r:embed="rId2">
+            <a:duotone>
+              <a:schemeClr val="bg2">
+                <a:shade val="45000"/>
+                <a:satMod val="135000"/>
+              </a:schemeClr>
+              <a:prstClr val="white"/>
+            </a:duotone>
+            <a:extLst>
+              <a:ext uri="{BEBA8EAE-BF5A-486C-A8C5-ECC9F3942E4B}">
+                <a14:imgProps xmlns:a14="http://schemas.microsoft.com/office/drawing/2010/main">
+                  <a14:imgLayer r:embed="rId3">
+                    <a14:imgEffect>
+                      <a14:artisticCutout/>
+                    </a14:imgEffect>
+                    <a14:imgEffect>
+                      <a14:saturation sat="0"/>
+                    </a14:imgEffect>
+                    <a14:imgEffect>
+                      <a14:brightnessContrast bright="40000" contrast="40000"/>
+                    </a14:imgEffect>
+                  </a14:imgLayer>
+                </a14:imgProps>
+              </a:ext>
+              <a:ext uri="{28A0092B-C50C-407E-A947-70E740481C1C}">
+                <a14:useLocalDpi xmlns:a14="http://schemas.microsoft.com/office/drawing/2010/main" val="0"/>
+              </a:ext>
+            </a:extLst>
+          </a:blip>
+          <a:stretch>
+            <a:fillRect/>
+          </a:stretch>
+        </p:blipFill>
+        <p:spPr>
+          <a:xfrm>
+            <a:off x="0" y="381000"/>
+            <a:ext cx="12192000" cy="6096000"/>
+          </a:xfrm>
+          <a:prstGeom prst="rect">
+            <a:avLst/>
+          </a:prstGeom>
+        </p:spPr>
+      </p:pic>
+      <p:sp>
+        <p:nvSpPr>
+          <p:cNvPr id="6" name="Rectangle 5">
+            <a:extLst>
+              <a:ext uri="{FF2B5EF4-FFF2-40B4-BE49-F238E27FC236}">
+                <a16:creationId xmlns:a16="http://schemas.microsoft.com/office/drawing/2014/main" id="{DD03AB48-C6E9-BD43-4EEA-B2FD96D544E2}"/>
+              </a:ext>
+            </a:extLst>
+          </p:cNvPr>
+          <p:cNvSpPr/>
+          <p:nvPr/>
+        </p:nvSpPr>
+        <p:spPr>
+          <a:xfrm>
+            <a:off x="914401" y="1333500"/>
+            <a:ext cx="10191750" cy="4219575"/>
+          </a:xfrm>
+          <a:prstGeom prst="rect">
+            <a:avLst/>
+          </a:prstGeom>
+          <a:ln>
+            <a:solidFill>
+              <a:schemeClr val="bg1"/>
+            </a:solidFill>
+          </a:ln>
+        </p:spPr>
+        <p:style>
+          <a:lnRef idx="2">
+            <a:schemeClr val="dk1"/>
+          </a:lnRef>
+          <a:fillRef idx="1">
+            <a:schemeClr val="lt1"/>
+          </a:fillRef>
+          <a:effectRef idx="0">
+            <a:schemeClr val="dk1"/>
+          </a:effectRef>
+          <a:fontRef idx="minor">
+            <a:schemeClr val="dk1"/>
+          </a:fontRef>
+        </p:style>
+        <p:txBody>
+          <a:bodyPr rtlCol="0" anchor="ctr"/>
+          <a:lstStyle/>
+          <a:p>
+            <a:pPr algn="ctr"/>
+            <a:endParaRPr lang="en-US"/>
+          </a:p>
+        </p:txBody>
+      </p:sp>
+      <p:pic>
+        <p:nvPicPr>
+          <p:cNvPr id="12" name="Picture 11">
+            <a:extLst>
+              <a:ext uri="{FF2B5EF4-FFF2-40B4-BE49-F238E27FC236}">
+                <a16:creationId xmlns:a16="http://schemas.microsoft.com/office/drawing/2014/main" id="{F343F6AC-52EB-0E48-63DD-45C09D8F2C49}"/>
+              </a:ext>
+            </a:extLst>
+          </p:cNvPr>
+          <p:cNvPicPr>
+            <a:picLocks noChangeAspect="1"/>
+          </p:cNvPicPr>
+          <p:nvPr/>
+        </p:nvPicPr>
+        <p:blipFill>
+          <a:blip r:embed="rId4"/>
+          <a:stretch>
+            <a:fillRect/>
+          </a:stretch>
+        </p:blipFill>
+        <p:spPr>
+          <a:xfrm>
+            <a:off x="1501967" y="1743075"/>
+            <a:ext cx="9202546" cy="3371850"/>
+          </a:xfrm>
+          <a:prstGeom prst="rect">
+            <a:avLst/>
+          </a:prstGeom>
+        </p:spPr>
+      </p:pic>
+    </p:spTree>
+    <p:extLst>
+      <p:ext uri="{BB962C8B-B14F-4D97-AF65-F5344CB8AC3E}">
+        <p14:creationId xmlns:p14="http://schemas.microsoft.com/office/powerpoint/2010/main" val="2690937209"/>
       </p:ext>
     </p:extLst>
   </p:cSld>

</xml_diff>